<commit_message>
change proportion to percentage
</commit_message>
<xml_diff>
--- a/Figures/2_proportions.pptx
+++ b/Figures/2_proportions.pptx
@@ -112,6 +112,59 @@
 </p:presentation>
 </file>
 
+<file path=ppt/revisionInfo.xml><?xml version="1.0" encoding="utf-8"?>
+<p1510:revInfo xmlns:a="http://schemas.openxmlformats.org/drawingml/2006/main" xmlns:r="http://schemas.openxmlformats.org/officeDocument/2006/relationships" xmlns:p1510="http://schemas.microsoft.com/office/powerpoint/2015/10/main">
+  <p1510:revLst>
+    <p1510:client id="{6238F8E6-298A-ED4E-90C0-FEE17FF04624}" v="2" dt="2025-07-21T17:46:07.676"/>
+  </p1510:revLst>
+</p1510:revInfo>
+</file>
+
+<file path=ppt/changesInfos/changesInfo1.xml><?xml version="1.0" encoding="utf-8"?>
+<pc:chgInfo xmlns:a="http://schemas.openxmlformats.org/drawingml/2006/main" xmlns:r="http://schemas.openxmlformats.org/officeDocument/2006/relationships" xmlns:ac="http://schemas.microsoft.com/office/drawing/2013/main/command" xmlns:pc="http://schemas.microsoft.com/office/powerpoint/2013/main/command">
+  <pc:docChgLst>
+    <pc:chgData name="Wooliver, Rachel" userId="89295863-75e5-4055-8ece-ead835fcf9fa" providerId="ADAL" clId="{6238F8E6-298A-ED4E-90C0-FEE17FF04624}"/>
+    <pc:docChg chg="undo custSel modSld">
+      <pc:chgData name="Wooliver, Rachel" userId="89295863-75e5-4055-8ece-ead835fcf9fa" providerId="ADAL" clId="{6238F8E6-298A-ED4E-90C0-FEE17FF04624}" dt="2025-07-21T17:47:40.813" v="31" actId="14100"/>
+      <pc:docMkLst>
+        <pc:docMk/>
+      </pc:docMkLst>
+      <pc:sldChg chg="modSp mod">
+        <pc:chgData name="Wooliver, Rachel" userId="89295863-75e5-4055-8ece-ead835fcf9fa" providerId="ADAL" clId="{6238F8E6-298A-ED4E-90C0-FEE17FF04624}" dt="2025-07-21T17:47:40.813" v="31" actId="14100"/>
+        <pc:sldMkLst>
+          <pc:docMk/>
+          <pc:sldMk cId="2705915003" sldId="256"/>
+        </pc:sldMkLst>
+        <pc:grpChg chg="mod">
+          <ac:chgData name="Wooliver, Rachel" userId="89295863-75e5-4055-8ece-ead835fcf9fa" providerId="ADAL" clId="{6238F8E6-298A-ED4E-90C0-FEE17FF04624}" dt="2025-07-21T17:47:40.813" v="31" actId="14100"/>
+          <ac:grpSpMkLst>
+            <pc:docMk/>
+            <pc:sldMk cId="2705915003" sldId="256"/>
+            <ac:grpSpMk id="24" creationId="{8DDC43BE-5224-0E78-925B-258939BE1F35}"/>
+          </ac:grpSpMkLst>
+        </pc:grpChg>
+        <pc:picChg chg="mod modCrop">
+          <ac:chgData name="Wooliver, Rachel" userId="89295863-75e5-4055-8ece-ead835fcf9fa" providerId="ADAL" clId="{6238F8E6-298A-ED4E-90C0-FEE17FF04624}" dt="2025-07-21T17:46:07.676" v="8" actId="14826"/>
+          <ac:picMkLst>
+            <pc:docMk/>
+            <pc:sldMk cId="2705915003" sldId="256"/>
+            <ac:picMk id="21" creationId="{F81FE19C-9634-BAE0-58F3-7761B2E0C6B1}"/>
+          </ac:picMkLst>
+        </pc:picChg>
+        <pc:picChg chg="mod modCrop">
+          <ac:chgData name="Wooliver, Rachel" userId="89295863-75e5-4055-8ece-ead835fcf9fa" providerId="ADAL" clId="{6238F8E6-298A-ED4E-90C0-FEE17FF04624}" dt="2025-07-21T17:47:16.197" v="21" actId="732"/>
+          <ac:picMkLst>
+            <pc:docMk/>
+            <pc:sldMk cId="2705915003" sldId="256"/>
+            <ac:picMk id="23" creationId="{9AB45692-496A-D860-FD35-665465944E5C}"/>
+          </ac:picMkLst>
+        </pc:picChg>
+      </pc:sldChg>
+    </pc:docChg>
+  </pc:docChgLst>
+</pc:chgInfo>
+</file>
+
 <file path=ppt/slideLayouts/slideLayout1.xml><?xml version="1.0" encoding="utf-8"?>
 <p:sldLayout xmlns:a="http://schemas.openxmlformats.org/drawingml/2006/main" xmlns:r="http://schemas.openxmlformats.org/officeDocument/2006/relationships" xmlns:p="http://schemas.openxmlformats.org/presentationml/2006/main" type="title" preserve="1">
   <p:cSld name="Title Slide">
@@ -243,7 +296,7 @@
           <a:p>
             <a:fld id="{94E8DF6F-CFDA-8D4E-AE4C-66BE41AC09DC}" type="datetimeFigureOut">
               <a:rPr lang="en-US" smtClean="0"/>
-              <a:t>4/4/25</a:t>
+              <a:t>7/21/25</a:t>
             </a:fld>
             <a:endParaRPr lang="en-US"/>
           </a:p>
@@ -413,7 +466,7 @@
           <a:p>
             <a:fld id="{94E8DF6F-CFDA-8D4E-AE4C-66BE41AC09DC}" type="datetimeFigureOut">
               <a:rPr lang="en-US" smtClean="0"/>
-              <a:t>4/4/25</a:t>
+              <a:t>7/21/25</a:t>
             </a:fld>
             <a:endParaRPr lang="en-US"/>
           </a:p>
@@ -593,7 +646,7 @@
           <a:p>
             <a:fld id="{94E8DF6F-CFDA-8D4E-AE4C-66BE41AC09DC}" type="datetimeFigureOut">
               <a:rPr lang="en-US" smtClean="0"/>
-              <a:t>4/4/25</a:t>
+              <a:t>7/21/25</a:t>
             </a:fld>
             <a:endParaRPr lang="en-US"/>
           </a:p>
@@ -763,7 +816,7 @@
           <a:p>
             <a:fld id="{94E8DF6F-CFDA-8D4E-AE4C-66BE41AC09DC}" type="datetimeFigureOut">
               <a:rPr lang="en-US" smtClean="0"/>
-              <a:t>4/4/25</a:t>
+              <a:t>7/21/25</a:t>
             </a:fld>
             <a:endParaRPr lang="en-US"/>
           </a:p>
@@ -1009,7 +1062,7 @@
           <a:p>
             <a:fld id="{94E8DF6F-CFDA-8D4E-AE4C-66BE41AC09DC}" type="datetimeFigureOut">
               <a:rPr lang="en-US" smtClean="0"/>
-              <a:t>4/4/25</a:t>
+              <a:t>7/21/25</a:t>
             </a:fld>
             <a:endParaRPr lang="en-US"/>
           </a:p>
@@ -1241,7 +1294,7 @@
           <a:p>
             <a:fld id="{94E8DF6F-CFDA-8D4E-AE4C-66BE41AC09DC}" type="datetimeFigureOut">
               <a:rPr lang="en-US" smtClean="0"/>
-              <a:t>4/4/25</a:t>
+              <a:t>7/21/25</a:t>
             </a:fld>
             <a:endParaRPr lang="en-US"/>
           </a:p>
@@ -1608,7 +1661,7 @@
           <a:p>
             <a:fld id="{94E8DF6F-CFDA-8D4E-AE4C-66BE41AC09DC}" type="datetimeFigureOut">
               <a:rPr lang="en-US" smtClean="0"/>
-              <a:t>4/4/25</a:t>
+              <a:t>7/21/25</a:t>
             </a:fld>
             <a:endParaRPr lang="en-US"/>
           </a:p>
@@ -1726,7 +1779,7 @@
           <a:p>
             <a:fld id="{94E8DF6F-CFDA-8D4E-AE4C-66BE41AC09DC}" type="datetimeFigureOut">
               <a:rPr lang="en-US" smtClean="0"/>
-              <a:t>4/4/25</a:t>
+              <a:t>7/21/25</a:t>
             </a:fld>
             <a:endParaRPr lang="en-US"/>
           </a:p>
@@ -1821,7 +1874,7 @@
           <a:p>
             <a:fld id="{94E8DF6F-CFDA-8D4E-AE4C-66BE41AC09DC}" type="datetimeFigureOut">
               <a:rPr lang="en-US" smtClean="0"/>
-              <a:t>4/4/25</a:t>
+              <a:t>7/21/25</a:t>
             </a:fld>
             <a:endParaRPr lang="en-US"/>
           </a:p>
@@ -2098,7 +2151,7 @@
           <a:p>
             <a:fld id="{94E8DF6F-CFDA-8D4E-AE4C-66BE41AC09DC}" type="datetimeFigureOut">
               <a:rPr lang="en-US" smtClean="0"/>
-              <a:t>4/4/25</a:t>
+              <a:t>7/21/25</a:t>
             </a:fld>
             <a:endParaRPr lang="en-US"/>
           </a:p>
@@ -2355,7 +2408,7 @@
           <a:p>
             <a:fld id="{94E8DF6F-CFDA-8D4E-AE4C-66BE41AC09DC}" type="datetimeFigureOut">
               <a:rPr lang="en-US" smtClean="0"/>
-              <a:t>4/4/25</a:t>
+              <a:t>7/21/25</a:t>
             </a:fld>
             <a:endParaRPr lang="en-US"/>
           </a:p>
@@ -2568,7 +2621,7 @@
           <a:p>
             <a:fld id="{94E8DF6F-CFDA-8D4E-AE4C-66BE41AC09DC}" type="datetimeFigureOut">
               <a:rPr lang="en-US" smtClean="0"/>
-              <a:t>4/4/25</a:t>
+              <a:t>7/21/25</a:t>
             </a:fld>
             <a:endParaRPr lang="en-US"/>
           </a:p>
@@ -2987,10 +3040,10 @@
         </p:nvGrpSpPr>
         <p:grpSpPr>
           <a:xfrm>
-            <a:off x="119037" y="22861"/>
-            <a:ext cx="5169243" cy="5943599"/>
+            <a:off x="0" y="0"/>
+            <a:ext cx="5486400" cy="5943600"/>
             <a:chOff x="0" y="0"/>
-            <a:chExt cx="5486400" cy="6480575"/>
+            <a:chExt cx="5486400" cy="6045768"/>
           </a:xfrm>
           <a:solidFill>
             <a:schemeClr val="bg1"/>
@@ -3012,13 +3065,15 @@
           </p:nvPicPr>
           <p:blipFill>
             <a:blip r:embed="rId2"/>
-            <a:srcRect b="11975"/>
-            <a:stretch/>
+            <a:srcRect t="709" b="11798"/>
+            <a:stretch>
+              <a:fillRect/>
+            </a:stretch>
           </p:blipFill>
           <p:spPr>
             <a:xfrm>
               <a:off x="0" y="0"/>
-              <a:ext cx="5486400" cy="3019143"/>
+              <a:ext cx="5486400" cy="3082140"/>
             </a:xfrm>
             <a:prstGeom prst="rect">
               <a:avLst/>
@@ -3042,13 +3097,15 @@
           </p:nvPicPr>
           <p:blipFill>
             <a:blip r:embed="rId3"/>
-            <a:srcRect t="1669" r="20592" b="-1669"/>
-            <a:stretch/>
+            <a:srcRect l="-1366" t="1454" r="19808" b="11984"/>
+            <a:stretch>
+              <a:fillRect/>
+            </a:stretch>
           </p:blipFill>
           <p:spPr>
             <a:xfrm>
-              <a:off x="0" y="3051577"/>
-              <a:ext cx="4355574" cy="3428998"/>
+              <a:off x="40987" y="3051577"/>
+              <a:ext cx="4358268" cy="2994191"/>
             </a:xfrm>
             <a:prstGeom prst="rect">
               <a:avLst/>

</xml_diff>